<commit_message>
Rebuild the deck: today's tests pushed its count out of band
collect_facts.py measures the suite; today's additions took it from 452 to
537, which is past the +-15% band test_the_deck_facts_are_current allows,
so the shipped .pptx was stale rather than approximately right.  Regenerated
both, and confirmed the slides actually carry the new number (537) rather
than only facts.json doing so -- rebuilding one and not the other is exactly
what that test exists to catch.

The release count moves 13 -> 14 in the same pass: it is `git tag` filtered
to v*, and v0.9.2 was tagged after the previous generation.

Co-Authored-By: Claude Fable 5 <noreply@anthropic.com>
Claude-Session: https://claude.ai/code/session_01E4u5MwBxcutcpDK8tWBdTz
</commit_message>
<xml_diff>
--- a/docs/reports/pllsim-项目总结-v0.9.2.pptx
+++ b/docs/reports/pllsim-项目总结-v0.9.2.pptx
@@ -1708,7 +1708,7 @@
                 <a:ea typeface="Microsoft YaHei" pitchFamily="34" charset="-122"/>
                 <a:cs typeface="Microsoft YaHei" pitchFamily="34" charset="-120"/>
               </a:rPr>
-              <a:t>v0.9.2    ·    6 种架构    ·    452 项自动化测试</a:t>
+              <a:t>v0.9.2    ·    6 种架构    ·    537 项自动化测试</a:t>
             </a:r>
             <a:endParaRPr lang="en-US" sz="1400" dirty="0"/>
           </a:p>
@@ -2737,7 +2737,7 @@
                 <a:ea typeface="Microsoft YaHei" pitchFamily="34" charset="-122"/>
                 <a:cs typeface="Microsoft YaHei" pitchFamily="34" charset="-120"/>
               </a:rPr>
-              <a:t>452</a:t>
+              <a:t>537</a:t>
             </a:r>
             <a:endParaRPr lang="en-US" sz="3400" dirty="0"/>
           </a:p>
@@ -7229,7 +7229,7 @@
                 <a:ea typeface="Microsoft YaHei" pitchFamily="34" charset="-122"/>
                 <a:cs typeface="Microsoft YaHei" pitchFamily="34" charset="-120"/>
               </a:rPr>
-              <a:t>452 项自动化测试，每次代码提交在两个 Python 版本上全量运行</a:t>
+              <a:t>537 项自动化测试，每次代码提交在两个 Python 版本上全量运行</a:t>
             </a:r>
             <a:endParaRPr lang="en-US" sz="1400" dirty="0"/>
           </a:p>
@@ -7932,7 +7932,7 @@
                 <a:ea typeface="Microsoft YaHei" pitchFamily="34" charset="-122"/>
                 <a:cs typeface="Microsoft YaHei" pitchFamily="34" charset="-120"/>
               </a:rPr>
-              <a:t>13 个版本全部带发布说明：每一个变动的数字都写明「哪个数变了、为什么」，不悄悄改基准。</a:t>
+              <a:t>14 个版本全部带发布说明：每一个变动的数字都写明「哪个数变了、为什么」，不悄悄改基准。</a:t>
             </a:r>
             <a:endParaRPr lang="en-US" sz="1450" dirty="0"/>
           </a:p>

</xml_diff>